<commit_message>
new AIDE + TITE
</commit_message>
<xml_diff>
--- a/Presentation 7-6-2026/Presentation 7-6-2026.pptx
+++ b/Presentation 7-6-2026/Presentation 7-6-2026.pptx
@@ -18,6 +18,7 @@
     <p:sldId id="277" r:id="rId12"/>
     <p:sldId id="278" r:id="rId13"/>
     <p:sldId id="274" r:id="rId14"/>
+    <p:sldId id="279" r:id="rId15"/>
   </p:sldIdLst>
   <p:sldSz cx="12192000" cy="6858000"/>
   <p:notesSz cx="6858000" cy="9144000"/>
@@ -127,9 +128,53 @@
 <file path=ppt/revisionInfo.xml><?xml version="1.0" encoding="utf-8"?>
 <p1510:revInfo xmlns:a="http://schemas.openxmlformats.org/drawingml/2006/main" xmlns:r="http://schemas.openxmlformats.org/officeDocument/2006/relationships" xmlns:p1510="http://schemas.microsoft.com/office/powerpoint/2015/10/main">
   <p1510:revLst>
-    <p1510:client id="{F55ADEBC-C445-4F07-B98B-58DDF703F24F}" v="1320" dt="2026-07-05T06:28:34.229"/>
+    <p1510:client id="{50C30DBB-9546-41CD-8C84-8188FB6F7970}" v="69" dt="2026-07-13T14:15:49.470"/>
   </p1510:revLst>
 </p1510:revInfo>
+</file>
+
+<file path=ppt/changesInfos/changesInfo1.xml><?xml version="1.0" encoding="utf-8"?>
+<pc:chgInfo xmlns:a="http://schemas.openxmlformats.org/drawingml/2006/main" xmlns:r="http://schemas.openxmlformats.org/officeDocument/2006/relationships" xmlns:ac="http://schemas.microsoft.com/office/drawing/2013/main/command" xmlns:pc="http://schemas.microsoft.com/office/powerpoint/2013/main/command">
+  <pc:docChgLst>
+    <pc:chgData name="Sicheng Yang" userId="9cd9ccf7fa329387" providerId="LiveId" clId="{B56CEE50-1CB5-4F22-9469-129262569FA4}"/>
+    <pc:docChg chg="custSel addSld modSld">
+      <pc:chgData name="Sicheng Yang" userId="9cd9ccf7fa329387" providerId="LiveId" clId="{B56CEE50-1CB5-4F22-9469-129262569FA4}" dt="2026-07-13T14:56:35.065" v="683" actId="20577"/>
+      <pc:docMkLst>
+        <pc:docMk/>
+      </pc:docMkLst>
+      <pc:sldChg chg="modSp mod">
+        <pc:chgData name="Sicheng Yang" userId="9cd9ccf7fa329387" providerId="LiveId" clId="{B56CEE50-1CB5-4F22-9469-129262569FA4}" dt="2026-07-13T14:15:49.469" v="70" actId="20577"/>
+        <pc:sldMkLst>
+          <pc:docMk/>
+          <pc:sldMk cId="3280140731" sldId="270"/>
+        </pc:sldMkLst>
+        <pc:spChg chg="mod">
+          <ac:chgData name="Sicheng Yang" userId="9cd9ccf7fa329387" providerId="LiveId" clId="{B56CEE50-1CB5-4F22-9469-129262569FA4}" dt="2026-07-13T14:15:49.469" v="70" actId="20577"/>
+          <ac:spMkLst>
+            <pc:docMk/>
+            <pc:sldMk cId="3280140731" sldId="270"/>
+            <ac:spMk id="3" creationId="{83E7D7DA-E6F2-DC95-15B7-FAC55E4BBDA1}"/>
+          </ac:spMkLst>
+        </pc:spChg>
+      </pc:sldChg>
+      <pc:sldChg chg="modSp new mod">
+        <pc:chgData name="Sicheng Yang" userId="9cd9ccf7fa329387" providerId="LiveId" clId="{B56CEE50-1CB5-4F22-9469-129262569FA4}" dt="2026-07-13T14:56:35.065" v="683" actId="20577"/>
+        <pc:sldMkLst>
+          <pc:docMk/>
+          <pc:sldMk cId="2301365047" sldId="279"/>
+        </pc:sldMkLst>
+        <pc:spChg chg="mod">
+          <ac:chgData name="Sicheng Yang" userId="9cd9ccf7fa329387" providerId="LiveId" clId="{B56CEE50-1CB5-4F22-9469-129262569FA4}" dt="2026-07-13T14:56:35.065" v="683" actId="20577"/>
+          <ac:spMkLst>
+            <pc:docMk/>
+            <pc:sldMk cId="2301365047" sldId="279"/>
+            <ac:spMk id="3" creationId="{263881F8-773D-DE8D-1BBC-0BCFDE8BC705}"/>
+          </ac:spMkLst>
+        </pc:spChg>
+      </pc:sldChg>
+    </pc:docChg>
+  </pc:docChgLst>
+</pc:chgInfo>
 </file>
 
 <file path=ppt/slideLayouts/slideLayout1.xml><?xml version="1.0" encoding="utf-8"?>
@@ -279,7 +324,7 @@
           <a:p>
             <a:fld id="{61B001A5-CFE6-40E7-8870-4EB3BD94D07C}" type="datetimeFigureOut">
               <a:rPr lang="en-US" smtClean="0"/>
-              <a:t>7/4/2026</a:t>
+              <a:t>7/13/2026</a:t>
             </a:fld>
             <a:endParaRPr lang="en-US"/>
           </a:p>
@@ -477,7 +522,7 @@
           <a:p>
             <a:fld id="{61B001A5-CFE6-40E7-8870-4EB3BD94D07C}" type="datetimeFigureOut">
               <a:rPr lang="en-US" smtClean="0"/>
-              <a:t>7/4/2026</a:t>
+              <a:t>7/13/2026</a:t>
             </a:fld>
             <a:endParaRPr lang="en-US"/>
           </a:p>
@@ -685,7 +730,7 @@
           <a:p>
             <a:fld id="{61B001A5-CFE6-40E7-8870-4EB3BD94D07C}" type="datetimeFigureOut">
               <a:rPr lang="en-US" smtClean="0"/>
-              <a:t>7/4/2026</a:t>
+              <a:t>7/13/2026</a:t>
             </a:fld>
             <a:endParaRPr lang="en-US"/>
           </a:p>
@@ -883,7 +928,7 @@
           <a:p>
             <a:fld id="{61B001A5-CFE6-40E7-8870-4EB3BD94D07C}" type="datetimeFigureOut">
               <a:rPr lang="en-US" smtClean="0"/>
-              <a:t>7/4/2026</a:t>
+              <a:t>7/13/2026</a:t>
             </a:fld>
             <a:endParaRPr lang="en-US"/>
           </a:p>
@@ -1158,7 +1203,7 @@
           <a:p>
             <a:fld id="{61B001A5-CFE6-40E7-8870-4EB3BD94D07C}" type="datetimeFigureOut">
               <a:rPr lang="en-US" smtClean="0"/>
-              <a:t>7/4/2026</a:t>
+              <a:t>7/13/2026</a:t>
             </a:fld>
             <a:endParaRPr lang="en-US"/>
           </a:p>
@@ -1423,7 +1468,7 @@
           <a:p>
             <a:fld id="{61B001A5-CFE6-40E7-8870-4EB3BD94D07C}" type="datetimeFigureOut">
               <a:rPr lang="en-US" smtClean="0"/>
-              <a:t>7/4/2026</a:t>
+              <a:t>7/13/2026</a:t>
             </a:fld>
             <a:endParaRPr lang="en-US"/>
           </a:p>
@@ -1835,7 +1880,7 @@
           <a:p>
             <a:fld id="{61B001A5-CFE6-40E7-8870-4EB3BD94D07C}" type="datetimeFigureOut">
               <a:rPr lang="en-US" smtClean="0"/>
-              <a:t>7/4/2026</a:t>
+              <a:t>7/13/2026</a:t>
             </a:fld>
             <a:endParaRPr lang="en-US"/>
           </a:p>
@@ -1976,7 +2021,7 @@
           <a:p>
             <a:fld id="{61B001A5-CFE6-40E7-8870-4EB3BD94D07C}" type="datetimeFigureOut">
               <a:rPr lang="en-US" smtClean="0"/>
-              <a:t>7/4/2026</a:t>
+              <a:t>7/13/2026</a:t>
             </a:fld>
             <a:endParaRPr lang="en-US"/>
           </a:p>
@@ -2089,7 +2134,7 @@
           <a:p>
             <a:fld id="{61B001A5-CFE6-40E7-8870-4EB3BD94D07C}" type="datetimeFigureOut">
               <a:rPr lang="en-US" smtClean="0"/>
-              <a:t>7/4/2026</a:t>
+              <a:t>7/13/2026</a:t>
             </a:fld>
             <a:endParaRPr lang="en-US"/>
           </a:p>
@@ -2400,7 +2445,7 @@
           <a:p>
             <a:fld id="{61B001A5-CFE6-40E7-8870-4EB3BD94D07C}" type="datetimeFigureOut">
               <a:rPr lang="en-US" smtClean="0"/>
-              <a:t>7/4/2026</a:t>
+              <a:t>7/13/2026</a:t>
             </a:fld>
             <a:endParaRPr lang="en-US"/>
           </a:p>
@@ -2688,7 +2733,7 @@
           <a:p>
             <a:fld id="{61B001A5-CFE6-40E7-8870-4EB3BD94D07C}" type="datetimeFigureOut">
               <a:rPr lang="en-US" smtClean="0"/>
-              <a:t>7/4/2026</a:t>
+              <a:t>7/13/2026</a:t>
             </a:fld>
             <a:endParaRPr lang="en-US"/>
           </a:p>
@@ -2929,7 +2974,7 @@
           <a:p>
             <a:fld id="{61B001A5-CFE6-40E7-8870-4EB3BD94D07C}" type="datetimeFigureOut">
               <a:rPr lang="en-US" smtClean="0"/>
-              <a:t>7/4/2026</a:t>
+              <a:t>7/13/2026</a:t>
             </a:fld>
             <a:endParaRPr lang="en-US"/>
           </a:p>
@@ -4684,8 +4729,8 @@
           </a:p>
         </p:txBody>
       </p:sp>
-      <mc:AlternateContent xmlns:mc="http://schemas.openxmlformats.org/markup-compatibility/2006">
-        <mc:Choice xmlns:a14="http://schemas.microsoft.com/office/drawing/2010/main" Requires="a14">
+      <mc:AlternateContent xmlns:mc="http://schemas.openxmlformats.org/markup-compatibility/2006" xmlns:a14="http://schemas.microsoft.com/office/drawing/2010/main">
+        <mc:Choice Requires="a14">
           <p:sp>
             <p:nvSpPr>
               <p:cNvPr id="3" name="Content Placeholder 2">
@@ -6197,7 +6242,7 @@
             </p:txBody>
           </p:sp>
         </mc:Choice>
-        <mc:Fallback>
+        <mc:Fallback xmlns="">
           <p:sp>
             <p:nvSpPr>
               <p:cNvPr id="3" name="Content Placeholder 2">
@@ -6292,8 +6337,8 @@
           </a:p>
         </p:txBody>
       </p:sp>
-      <mc:AlternateContent xmlns:mc="http://schemas.openxmlformats.org/markup-compatibility/2006">
-        <mc:Choice xmlns:a14="http://schemas.microsoft.com/office/drawing/2010/main" Requires="a14">
+      <mc:AlternateContent xmlns:mc="http://schemas.openxmlformats.org/markup-compatibility/2006" xmlns:a14="http://schemas.microsoft.com/office/drawing/2010/main">
+        <mc:Choice Requires="a14">
           <p:sp>
             <p:nvSpPr>
               <p:cNvPr id="3" name="Content Placeholder 2">
@@ -6515,13 +6560,7 @@
                               <a:rPr lang="en-US" i="1">
                                 <a:latin typeface="Cambria Math" panose="02040503050406030204" pitchFamily="18" charset="0"/>
                               </a:rPr>
-                              <m:t>10</m:t>
-                            </m:r>
-                            <m:r>
-                              <a:rPr lang="en-US" i="1">
-                                <a:latin typeface="Cambria Math" panose="02040503050406030204" pitchFamily="18" charset="0"/>
-                              </a:rPr>
-                              <m:t>,</m:t>
+                              <m:t>10,</m:t>
                             </m:r>
                             <m:r>
                               <a:rPr lang="en-US" i="1">
@@ -6583,13 +6622,7 @@
                               <a:rPr lang="en-US" i="1">
                                 <a:latin typeface="Cambria Math" panose="02040503050406030204" pitchFamily="18" charset="0"/>
                               </a:rPr>
-                              <m:t>11</m:t>
-                            </m:r>
-                            <m:r>
-                              <a:rPr lang="en-US" i="1">
-                                <a:latin typeface="Cambria Math" panose="02040503050406030204" pitchFamily="18" charset="0"/>
-                              </a:rPr>
-                              <m:t>,</m:t>
+                              <m:t>11,</m:t>
                             </m:r>
                             <m:r>
                               <a:rPr lang="en-US" i="1">
@@ -6790,7 +6823,7 @@
             </p:txBody>
           </p:sp>
         </mc:Choice>
-        <mc:Fallback>
+        <mc:Fallback xmlns="">
           <p:sp>
             <p:nvSpPr>
               <p:cNvPr id="3" name="Content Placeholder 2">
@@ -6888,8 +6921,8 @@
           </a:p>
         </p:txBody>
       </p:sp>
-      <mc:AlternateContent xmlns:mc="http://schemas.openxmlformats.org/markup-compatibility/2006">
-        <mc:Choice xmlns:a14="http://schemas.microsoft.com/office/drawing/2010/main" Requires="a14">
+      <mc:AlternateContent xmlns:mc="http://schemas.openxmlformats.org/markup-compatibility/2006" xmlns:a14="http://schemas.microsoft.com/office/drawing/2010/main">
+        <mc:Choice Requires="a14">
           <p:sp>
             <p:nvSpPr>
               <p:cNvPr id="3" name="Content Placeholder 2">
@@ -7781,7 +7814,7 @@
             </p:txBody>
           </p:sp>
         </mc:Choice>
-        <mc:Fallback>
+        <mc:Fallback xmlns="">
           <p:sp>
             <p:nvSpPr>
               <p:cNvPr id="3" name="Content Placeholder 2">
@@ -7825,6 +7858,133 @@
     <p:extLst>
       <p:ext uri="{BB962C8B-B14F-4D97-AF65-F5344CB8AC3E}">
         <p14:creationId xmlns:p14="http://schemas.microsoft.com/office/powerpoint/2010/main" val="3218160782"/>
+      </p:ext>
+    </p:extLst>
+  </p:cSld>
+  <p:clrMapOvr>
+    <a:masterClrMapping/>
+  </p:clrMapOvr>
+</p:sld>
+</file>
+
+<file path=ppt/slides/slide14.xml><?xml version="1.0" encoding="utf-8"?>
+<p:sld xmlns:a="http://schemas.openxmlformats.org/drawingml/2006/main" xmlns:r="http://schemas.openxmlformats.org/officeDocument/2006/relationships" xmlns:p="http://schemas.openxmlformats.org/presentationml/2006/main">
+  <p:cSld>
+    <p:spTree>
+      <p:nvGrpSpPr>
+        <p:cNvPr id="1" name=""/>
+        <p:cNvGrpSpPr/>
+        <p:nvPr/>
+      </p:nvGrpSpPr>
+      <p:grpSpPr>
+        <a:xfrm>
+          <a:off x="0" y="0"/>
+          <a:ext cx="0" cy="0"/>
+          <a:chOff x="0" y="0"/>
+          <a:chExt cx="0" cy="0"/>
+        </a:xfrm>
+      </p:grpSpPr>
+      <p:sp>
+        <p:nvSpPr>
+          <p:cNvPr id="2" name="Title 1">
+            <a:extLst>
+              <a:ext uri="{FF2B5EF4-FFF2-40B4-BE49-F238E27FC236}">
+                <a16:creationId xmlns:a16="http://schemas.microsoft.com/office/drawing/2014/main" id="{AE55DB08-BEBA-7EA8-A512-5A5DC2911559}"/>
+              </a:ext>
+            </a:extLst>
+          </p:cNvPr>
+          <p:cNvSpPr>
+            <a:spLocks noGrp="1"/>
+          </p:cNvSpPr>
+          <p:nvPr>
+            <p:ph type="title"/>
+          </p:nvPr>
+        </p:nvSpPr>
+        <p:spPr/>
+        <p:txBody>
+          <a:bodyPr/>
+          <a:lstStyle/>
+          <a:p>
+            <a:endParaRPr lang="en-US" dirty="0"/>
+          </a:p>
+        </p:txBody>
+      </p:sp>
+      <p:sp>
+        <p:nvSpPr>
+          <p:cNvPr id="3" name="Content Placeholder 2">
+            <a:extLst>
+              <a:ext uri="{FF2B5EF4-FFF2-40B4-BE49-F238E27FC236}">
+                <a16:creationId xmlns:a16="http://schemas.microsoft.com/office/drawing/2014/main" id="{263881F8-773D-DE8D-1BBC-0BCFDE8BC705}"/>
+              </a:ext>
+            </a:extLst>
+          </p:cNvPr>
+          <p:cNvSpPr>
+            <a:spLocks noGrp="1"/>
+          </p:cNvSpPr>
+          <p:nvPr>
+            <p:ph idx="1"/>
+          </p:nvPr>
+        </p:nvSpPr>
+        <p:spPr/>
+        <p:txBody>
+          <a:bodyPr>
+            <a:normAutofit fontScale="92500"/>
+          </a:bodyPr>
+          <a:lstStyle/>
+          <a:p>
+            <a:r>
+              <a:rPr lang="en-US" dirty="0"/>
+              <a:t>Measure to quantify variability in MTD selection </a:t>
+            </a:r>
+          </a:p>
+          <a:p>
+            <a:r>
+              <a:rPr lang="en-US" dirty="0"/>
+              <a:t>Suspension in trial design + 3 evaluated patient </a:t>
+            </a:r>
+          </a:p>
+          <a:p>
+            <a:r>
+              <a:rPr lang="en-US" dirty="0"/>
+              <a:t>Remove rule 5 no skipping</a:t>
+            </a:r>
+          </a:p>
+          <a:p>
+            <a:r>
+              <a:rPr lang="en-US" dirty="0"/>
+              <a:t>For original AIDE, consider patient arrival time, prioritize new patient </a:t>
+            </a:r>
+          </a:p>
+          <a:p>
+            <a:r>
+              <a:rPr lang="en-US" dirty="0"/>
+              <a:t>Toxicity – power model, efficacy – beta-binomial, two stage</a:t>
+            </a:r>
+          </a:p>
+          <a:p>
+            <a:r>
+              <a:rPr lang="en-US" dirty="0"/>
+              <a:t>(1,0),(0,1),(0,0),(1,1) multinomial, constraint on p1 + p3 marginal of toxicity</a:t>
+            </a:r>
+          </a:p>
+          <a:p>
+            <a:r>
+              <a:rPr lang="en-US" dirty="0"/>
+              <a:t>YT,YE | Z = 0 = (p1,p2,p3,p4), correlation parameter rho</a:t>
+            </a:r>
+          </a:p>
+          <a:p>
+            <a:r>
+              <a:rPr lang="en-US" dirty="0"/>
+              <a:t>YT,YE | Z = 1 = (p1*, p2*, p3*, p4*), same correlation parameter rho</a:t>
+            </a:r>
+          </a:p>
+        </p:txBody>
+      </p:sp>
+    </p:spTree>
+    <p:extLst>
+      <p:ext uri="{BB962C8B-B14F-4D97-AF65-F5344CB8AC3E}">
+        <p14:creationId xmlns:p14="http://schemas.microsoft.com/office/powerpoint/2010/main" val="2301365047"/>
       </p:ext>
     </p:extLst>
   </p:cSld>
@@ -8994,8 +9154,8 @@
           </a:p>
         </p:txBody>
       </p:sp>
-      <mc:AlternateContent xmlns:mc="http://schemas.openxmlformats.org/markup-compatibility/2006" xmlns:a14="http://schemas.microsoft.com/office/drawing/2010/main">
-        <mc:Choice Requires="a14">
+      <mc:AlternateContent xmlns:mc="http://schemas.openxmlformats.org/markup-compatibility/2006">
+        <mc:Choice xmlns:a14="http://schemas.microsoft.com/office/drawing/2010/main" Requires="a14">
           <p:sp>
             <p:nvSpPr>
               <p:cNvPr id="3" name="Content Placeholder 2">
@@ -9888,68 +10048,258 @@
                       </a:rPr>
                       <m:t>𝑏𝑒𝑡𝑎</m:t>
                     </m:r>
+                    <m:d>
+                      <m:dPr>
+                        <m:ctrlPr>
+                          <a:rPr lang="en-US" b="0" i="1" smtClean="0">
+                            <a:latin typeface="Cambria Math" panose="02040503050406030204" pitchFamily="18" charset="0"/>
+                          </a:rPr>
+                        </m:ctrlPr>
+                      </m:dPr>
+                      <m:e>
+                        <m:f>
+                          <m:fPr>
+                            <m:ctrlPr>
+                              <a:rPr lang="en-US" b="0" i="1" smtClean="0">
+                                <a:latin typeface="Cambria Math" panose="02040503050406030204" pitchFamily="18" charset="0"/>
+                              </a:rPr>
+                            </m:ctrlPr>
+                          </m:fPr>
+                          <m:num>
+                            <m:r>
+                              <a:rPr lang="en-US" b="0" i="1" smtClean="0">
+                                <a:latin typeface="Cambria Math" panose="02040503050406030204" pitchFamily="18" charset="0"/>
+                              </a:rPr>
+                              <m:t>𝜙</m:t>
+                            </m:r>
+                          </m:num>
+                          <m:den>
+                            <m:r>
+                              <a:rPr lang="en-US" b="0" i="1" smtClean="0">
+                                <a:latin typeface="Cambria Math" panose="02040503050406030204" pitchFamily="18" charset="0"/>
+                              </a:rPr>
+                              <m:t>2</m:t>
+                            </m:r>
+                          </m:den>
+                        </m:f>
+                        <m:r>
+                          <a:rPr lang="en-US" b="0" i="1" smtClean="0">
+                            <a:latin typeface="Cambria Math" panose="02040503050406030204" pitchFamily="18" charset="0"/>
+                          </a:rPr>
+                          <m:t>, 1−</m:t>
+                        </m:r>
+                        <m:f>
+                          <m:fPr>
+                            <m:ctrlPr>
+                              <a:rPr lang="en-US" b="0" i="1" smtClean="0">
+                                <a:latin typeface="Cambria Math" panose="02040503050406030204" pitchFamily="18" charset="0"/>
+                              </a:rPr>
+                            </m:ctrlPr>
+                          </m:fPr>
+                          <m:num>
+                            <m:r>
+                              <a:rPr lang="en-US" b="0" i="1" smtClean="0">
+                                <a:latin typeface="Cambria Math" panose="02040503050406030204" pitchFamily="18" charset="0"/>
+                              </a:rPr>
+                              <m:t>𝜙</m:t>
+                            </m:r>
+                          </m:num>
+                          <m:den>
+                            <m:r>
+                              <a:rPr lang="en-US" b="0" i="1" smtClean="0">
+                                <a:latin typeface="Cambria Math" panose="02040503050406030204" pitchFamily="18" charset="0"/>
+                              </a:rPr>
+                              <m:t>2</m:t>
+                            </m:r>
+                          </m:den>
+                        </m:f>
+                      </m:e>
+                    </m:d>
+                    <m:r>
+                      <a:rPr lang="en-US" b="0" i="1" smtClean="0">
+                        <a:latin typeface="Cambria Math" panose="02040503050406030204" pitchFamily="18" charset="0"/>
+                      </a:rPr>
+                      <m:t>,</m:t>
+                    </m:r>
+                    <m:r>
+                      <a:rPr lang="en-US" b="0" i="1" smtClean="0">
+                        <a:latin typeface="Cambria Math" panose="02040503050406030204" pitchFamily="18" charset="0"/>
+                      </a:rPr>
+                      <m:t>𝑏𝑒𝑡𝑎</m:t>
+                    </m:r>
+                    <m:d>
+                      <m:dPr>
+                        <m:ctrlPr>
+                          <a:rPr lang="en-US" b="0" i="1" smtClean="0">
+                            <a:latin typeface="Cambria Math" panose="02040503050406030204" pitchFamily="18" charset="0"/>
+                          </a:rPr>
+                        </m:ctrlPr>
+                      </m:dPr>
+                      <m:e>
+                        <m:r>
+                          <a:rPr lang="en-US" b="0" i="1" smtClean="0">
+                            <a:latin typeface="Cambria Math" panose="02040503050406030204" pitchFamily="18" charset="0"/>
+                          </a:rPr>
+                          <m:t>1,1</m:t>
+                        </m:r>
+                      </m:e>
+                    </m:d>
+                    <m:r>
+                      <a:rPr lang="en-US" b="0" i="1" smtClean="0">
+                        <a:latin typeface="Cambria Math" panose="02040503050406030204" pitchFamily="18" charset="0"/>
+                      </a:rPr>
+                      <m:t>, </m:t>
+                    </m:r>
+                    <m:r>
+                      <a:rPr lang="en-US" b="0" i="1" smtClean="0">
+                        <a:latin typeface="Cambria Math" panose="02040503050406030204" pitchFamily="18" charset="0"/>
+                      </a:rPr>
+                      <m:t>𝑏𝑒𝑡𝑎</m:t>
+                    </m:r>
+                    <m:r>
+                      <a:rPr lang="en-US" b="0" i="1" smtClean="0">
+                        <a:latin typeface="Cambria Math" panose="02040503050406030204" pitchFamily="18" charset="0"/>
+                      </a:rPr>
+                      <m:t>(0.5,0.5)</m:t>
+                    </m:r>
+                  </m:oMath>
+                </a14:m>
+                <a:r>
+                  <a:rPr lang="en-US" dirty="0"/>
+                  <a:t> </a:t>
+                </a:r>
+              </a:p>
+              <a:p>
+                <a14:m>
+                  <m:oMath xmlns:m="http://schemas.openxmlformats.org/officeDocument/2006/math">
+                    <m:sSub>
+                      <m:sSubPr>
+                        <m:ctrlPr>
+                          <a:rPr lang="en-US" b="0" i="1" smtClean="0">
+                            <a:latin typeface="Cambria Math" panose="02040503050406030204" pitchFamily="18" charset="0"/>
+                          </a:rPr>
+                        </m:ctrlPr>
+                      </m:sSubPr>
+                      <m:e>
+                        <m:r>
+                          <a:rPr lang="en-US" b="0" i="1" smtClean="0">
+                            <a:latin typeface="Cambria Math" panose="02040503050406030204" pitchFamily="18" charset="0"/>
+                          </a:rPr>
+                          <m:t>𝐴</m:t>
+                        </m:r>
+                      </m:e>
+                      <m:sub>
+                        <m:r>
+                          <a:rPr lang="en-US" b="0" i="1" smtClean="0">
+                            <a:latin typeface="Cambria Math" panose="02040503050406030204" pitchFamily="18" charset="0"/>
+                          </a:rPr>
+                          <m:t>𝑖</m:t>
+                        </m:r>
+                      </m:sub>
+                    </m:sSub>
+                    <m:r>
+                      <a:rPr lang="en-US" b="0" i="1" smtClean="0">
+                        <a:latin typeface="Cambria Math" panose="02040503050406030204" pitchFamily="18" charset="0"/>
+                      </a:rPr>
+                      <m:t>~</m:t>
+                    </m:r>
+                    <m:r>
+                      <a:rPr lang="en-US" b="0" i="1" smtClean="0">
+                        <a:latin typeface="Cambria Math" panose="02040503050406030204" pitchFamily="18" charset="0"/>
+                      </a:rPr>
+                      <m:t>𝐵𝑟</m:t>
+                    </m:r>
+                    <m:d>
+                      <m:dPr>
+                        <m:ctrlPr>
+                          <a:rPr lang="en-US" b="0" i="1" smtClean="0">
+                            <a:latin typeface="Cambria Math" panose="02040503050406030204" pitchFamily="18" charset="0"/>
+                          </a:rPr>
+                        </m:ctrlPr>
+                      </m:dPr>
+                      <m:e>
+                        <m:sSub>
+                          <m:sSubPr>
+                            <m:ctrlPr>
+                              <a:rPr lang="en-US" b="0" i="1" smtClean="0">
+                                <a:latin typeface="Cambria Math" panose="02040503050406030204" pitchFamily="18" charset="0"/>
+                              </a:rPr>
+                            </m:ctrlPr>
+                          </m:sSubPr>
+                          <m:e>
+                            <m:r>
+                              <a:rPr lang="en-US" b="0" i="1" smtClean="0">
+                                <a:latin typeface="Cambria Math" panose="02040503050406030204" pitchFamily="18" charset="0"/>
+                              </a:rPr>
+                              <m:t>𝑝</m:t>
+                            </m:r>
+                          </m:e>
+                          <m:sub>
+                            <m:r>
+                              <a:rPr lang="en-US" b="0" i="1" smtClean="0">
+                                <a:latin typeface="Cambria Math" panose="02040503050406030204" pitchFamily="18" charset="0"/>
+                              </a:rPr>
+                              <m:t>2</m:t>
+                            </m:r>
+                          </m:sub>
+                        </m:sSub>
+                      </m:e>
+                    </m:d>
+                    <m:r>
+                      <a:rPr lang="en-US" b="0" i="1" smtClean="0">
+                        <a:latin typeface="Cambria Math" panose="02040503050406030204" pitchFamily="18" charset="0"/>
+                      </a:rPr>
+                      <m:t>, </m:t>
+                    </m:r>
+                    <m:sSub>
+                      <m:sSubPr>
+                        <m:ctrlPr>
+                          <a:rPr lang="en-US" b="0" i="1" smtClean="0">
+                            <a:latin typeface="Cambria Math" panose="02040503050406030204" pitchFamily="18" charset="0"/>
+                          </a:rPr>
+                        </m:ctrlPr>
+                      </m:sSubPr>
+                      <m:e>
+                        <m:r>
+                          <a:rPr lang="en-US" b="0" i="1" smtClean="0">
+                            <a:latin typeface="Cambria Math" panose="02040503050406030204" pitchFamily="18" charset="0"/>
+                          </a:rPr>
+                          <m:t>𝐶</m:t>
+                        </m:r>
+                      </m:e>
+                      <m:sub>
+                        <m:r>
+                          <a:rPr lang="en-US" b="0" i="1" smtClean="0">
+                            <a:latin typeface="Cambria Math" panose="02040503050406030204" pitchFamily="18" charset="0"/>
+                          </a:rPr>
+                          <m:t>𝑖</m:t>
+                        </m:r>
+                      </m:sub>
+                    </m:sSub>
+                    <m:r>
+                      <a:rPr lang="en-US" b="0" i="1" smtClean="0">
+                        <a:latin typeface="Cambria Math" panose="02040503050406030204" pitchFamily="18" charset="0"/>
+                      </a:rPr>
+                      <m:t>~</m:t>
+                    </m:r>
+                    <m:r>
+                      <a:rPr lang="en-US" b="0" i="1" smtClean="0">
+                        <a:latin typeface="Cambria Math" panose="02040503050406030204" pitchFamily="18" charset="0"/>
+                      </a:rPr>
+                      <m:t>𝐵𝑟</m:t>
+                    </m:r>
                     <m:r>
                       <a:rPr lang="en-US" b="0" i="1" smtClean="0">
                         <a:latin typeface="Cambria Math" panose="02040503050406030204" pitchFamily="18" charset="0"/>
                       </a:rPr>
                       <m:t>(</m:t>
                     </m:r>
-                    <m:f>
-                      <m:fPr>
-                        <m:ctrlPr>
-                          <a:rPr lang="en-US" b="0" i="1" smtClean="0">
-                            <a:latin typeface="Cambria Math" panose="02040503050406030204" pitchFamily="18" charset="0"/>
-                          </a:rPr>
-                        </m:ctrlPr>
-                      </m:fPr>
-                      <m:num>
-                        <m:r>
-                          <a:rPr lang="en-US" b="0" i="1" smtClean="0">
-                            <a:latin typeface="Cambria Math" panose="02040503050406030204" pitchFamily="18" charset="0"/>
-                          </a:rPr>
-                          <m:t>𝜙</m:t>
-                        </m:r>
-                      </m:num>
-                      <m:den>
-                        <m:r>
-                          <a:rPr lang="en-US" b="0" i="1" smtClean="0">
-                            <a:latin typeface="Cambria Math" panose="02040503050406030204" pitchFamily="18" charset="0"/>
-                          </a:rPr>
-                          <m:t>2</m:t>
-                        </m:r>
-                      </m:den>
-                    </m:f>
-                    <m:r>
-                      <a:rPr lang="en-US" b="0" i="1" smtClean="0">
-                        <a:latin typeface="Cambria Math" panose="02040503050406030204" pitchFamily="18" charset="0"/>
-                      </a:rPr>
-                      <m:t>, 1−</m:t>
-                    </m:r>
-                    <m:f>
-                      <m:fPr>
-                        <m:ctrlPr>
-                          <a:rPr lang="en-US" b="0" i="1" smtClean="0">
-                            <a:latin typeface="Cambria Math" panose="02040503050406030204" pitchFamily="18" charset="0"/>
-                          </a:rPr>
-                        </m:ctrlPr>
-                      </m:fPr>
-                      <m:num>
-                        <m:r>
-                          <a:rPr lang="en-US" b="0" i="1" smtClean="0">
-                            <a:latin typeface="Cambria Math" panose="02040503050406030204" pitchFamily="18" charset="0"/>
-                          </a:rPr>
-                          <m:t>𝜙</m:t>
-                        </m:r>
-                      </m:num>
-                      <m:den>
-                        <m:r>
-                          <a:rPr lang="en-US" b="0" i="1" smtClean="0">
-                            <a:latin typeface="Cambria Math" panose="02040503050406030204" pitchFamily="18" charset="0"/>
-                          </a:rPr>
-                          <m:t>2</m:t>
-                        </m:r>
-                      </m:den>
-                    </m:f>
+                    <m:r>
+                      <a:rPr lang="en-US" b="0" i="1" smtClean="0">
+                        <a:latin typeface="Cambria Math" panose="02040503050406030204" pitchFamily="18" charset="0"/>
+                      </a:rPr>
+                      <m:t>𝑟</m:t>
+                    </m:r>
                     <m:r>
                       <a:rPr lang="en-US" b="0" i="1" smtClean="0">
                         <a:latin typeface="Cambria Math" panose="02040503050406030204" pitchFamily="18" charset="0"/>
@@ -9963,7 +10313,7 @@
             </p:txBody>
           </p:sp>
         </mc:Choice>
-        <mc:Fallback xmlns="">
+        <mc:Fallback>
           <p:sp>
             <p:nvSpPr>
               <p:cNvPr id="3" name="Content Placeholder 2">

</xml_diff>